<commit_message>
Site-livery template: medallion mark, plain Helvetica
</commit_message>
<xml_diff>
--- a/files/TRG-template-site.pptx
+++ b/files/TRG-template-site.pptx
@@ -1293,7 +1293,7 @@
       </p:sp>
       <p:pic>
         <p:nvPicPr>
-          <p:cNvPr id="5" name="Image 0" descr="mark-hazard.png">    </p:cNvPr>
+          <p:cNvPr id="5" name="Image 0" descr="medallion-tri.png">    </p:cNvPr>
           <p:cNvPicPr>
             <a:picLocks noChangeAspect="1"/>
           </p:cNvPicPr>
@@ -1307,8 +1307,8 @@
         </p:blipFill>
         <p:spPr>
           <a:xfrm>
-            <a:off x="822960" y="1005840"/>
-            <a:ext cx="2651760" cy="1325880"/>
+            <a:off x="822960" y="1051560"/>
+            <a:ext cx="1051560" cy="1051560"/>
           </a:xfrm>
           <a:prstGeom prst="rect">
             <a:avLst/>
@@ -1318,6 +1318,68 @@
       <p:sp>
         <p:nvSpPr>
           <p:cNvPr id="6" name="Text 3"/>
+          <p:cNvSpPr txBox="1"/>
+          <p:nvPr/>
+        </p:nvSpPr>
+        <p:spPr>
+          <a:xfrm>
+            <a:off x="2103120" y="1170432"/>
+            <a:ext cx="5486400" cy="914400"/>
+          </a:xfrm>
+          <a:prstGeom prst="rect">
+            <a:avLst/>
+          </a:prstGeom>
+          <a:noFill/>
+          <a:ln/>
+        </p:spPr>
+        <p:txBody>
+          <a:bodyPr wrap="square" lIns="0" tIns="0" rIns="0" bIns="0" rtlCol="0" anchor="ctr"/>
+          <a:lstStyle/>
+          <a:p>
+            <a:pPr indent="0" marL="0">
+              <a:lnSpc>
+                <a:spcPts val="2600"/>
+              </a:lnSpc>
+              <a:buNone/>
+            </a:pPr>
+            <a:r>
+              <a:rPr lang="en-US" sz="1900" b="1" dirty="0">
+                <a:solidFill>
+                  <a:srgbClr val="1A1D1B"/>
+                </a:solidFill>
+                <a:latin typeface="Helvetica" pitchFamily="34" charset="0"/>
+                <a:ea typeface="Helvetica" pitchFamily="34" charset="-122"/>
+                <a:cs typeface="Helvetica" pitchFamily="34" charset="-120"/>
+              </a:rPr>
+              <a:t>Taciroglu Research Group</a:t>
+            </a:r>
+            <a:endParaRPr lang="en-US" sz="1900" dirty="0"/>
+          </a:p>
+          <a:p>
+            <a:pPr indent="0" marL="0">
+              <a:lnSpc>
+                <a:spcPts val="2600"/>
+              </a:lnSpc>
+              <a:buNone/>
+            </a:pPr>
+            <a:r>
+              <a:rPr lang="en-US" sz="1900" dirty="0">
+                <a:solidFill>
+                  <a:srgbClr val="1A1D1B"/>
+                </a:solidFill>
+                <a:latin typeface="Helvetica" pitchFamily="34" charset="0"/>
+                <a:ea typeface="Helvetica" pitchFamily="34" charset="-122"/>
+                <a:cs typeface="Helvetica" pitchFamily="34" charset="-120"/>
+              </a:rPr>
+              <a:t>UCLA</a:t>
+            </a:r>
+            <a:endParaRPr lang="en-US" sz="1900" dirty="0"/>
+          </a:p>
+        </p:txBody>
+      </p:sp>
+      <p:sp>
+        <p:nvSpPr>
+          <p:cNvPr id="7" name="Text 4"/>
           <p:cNvSpPr txBox="1"/>
           <p:nvPr/>
         </p:nvSpPr>
@@ -1356,7 +1418,7 @@
       </p:sp>
       <p:sp>
         <p:nvSpPr>
-          <p:cNvPr id="7" name="Text 4"/>
+          <p:cNvPr id="8" name="Text 5"/>
           <p:cNvSpPr txBox="1"/>
           <p:nvPr/>
         </p:nvSpPr>
@@ -1395,7 +1457,7 @@
       </p:sp>
       <p:sp>
         <p:nvSpPr>
-          <p:cNvPr id="8" name="Text 5"/>
+          <p:cNvPr id="9" name="Text 6"/>
           <p:cNvSpPr txBox="1"/>
           <p:nvPr/>
         </p:nvSpPr>
@@ -1477,7 +1539,7 @@
       </p:sp>
       <p:sp>
         <p:nvSpPr>
-          <p:cNvPr id="9" name="Shape 6"/>
+          <p:cNvPr id="10" name="Shape 7"/>
           <p:cNvSpPr/>
           <p:nvPr/>
         </p:nvSpPr>
@@ -2886,7 +2948,7 @@
       </p:sp>
       <p:pic>
         <p:nvPicPr>
-          <p:cNvPr id="6" name="Image 0" descr="medallion.png">    </p:cNvPr>
+          <p:cNvPr id="6" name="Image 0" descr="medallion-tri-dark.png">    </p:cNvPr>
           <p:cNvPicPr>
             <a:picLocks noChangeAspect="1"/>
           </p:cNvPicPr>

</xml_diff>

<commit_message>
Update templates with UCLA mark
</commit_message>
<xml_diff>
--- a/files/TRG-template-site.pptx
+++ b/files/TRG-template-site.pptx
@@ -1291,9 +1291,48 @@
           <a:ln/>
         </p:spPr>
       </p:sp>
+      <p:sp>
+        <p:nvSpPr>
+          <p:cNvPr id="5" name="Text 3"/>
+          <p:cNvSpPr txBox="1"/>
+          <p:nvPr/>
+        </p:nvSpPr>
+        <p:spPr>
+          <a:xfrm>
+            <a:off x="10497312" y="320040"/>
+            <a:ext cx="1188720" cy="502920"/>
+          </a:xfrm>
+          <a:prstGeom prst="rect">
+            <a:avLst/>
+          </a:prstGeom>
+          <a:noFill/>
+          <a:ln/>
+        </p:spPr>
+        <p:txBody>
+          <a:bodyPr wrap="square" lIns="0" tIns="0" rIns="0" bIns="0" rtlCol="0" anchor="ctr"/>
+          <a:lstStyle/>
+          <a:p>
+            <a:pPr algn="r" indent="0" marL="0">
+              <a:buNone/>
+            </a:pPr>
+            <a:r>
+              <a:rPr lang="en-US" sz="2600" b="1" i="1" dirty="0">
+                <a:solidFill>
+                  <a:srgbClr val="2774AE"/>
+                </a:solidFill>
+                <a:latin typeface="Helvetica" pitchFamily="34" charset="0"/>
+                <a:ea typeface="Helvetica" pitchFamily="34" charset="-122"/>
+                <a:cs typeface="Helvetica" pitchFamily="34" charset="-120"/>
+              </a:rPr>
+              <a:t>UCLA</a:t>
+            </a:r>
+            <a:endParaRPr lang="en-US" sz="2600" dirty="0"/>
+          </a:p>
+        </p:txBody>
+      </p:sp>
       <p:pic>
         <p:nvPicPr>
-          <p:cNvPr id="5" name="Image 0" descr="medallion-tri.png">    </p:cNvPr>
+          <p:cNvPr id="6" name="Image 0" descr="medallion-tri.png">    </p:cNvPr>
           <p:cNvPicPr>
             <a:picLocks noChangeAspect="1"/>
           </p:cNvPicPr>
@@ -1317,7 +1356,7 @@
       </p:pic>
       <p:sp>
         <p:nvSpPr>
-          <p:cNvPr id="6" name="Text 3"/>
+          <p:cNvPr id="7" name="Text 4"/>
           <p:cNvSpPr txBox="1"/>
           <p:nvPr/>
         </p:nvSpPr>
@@ -1379,7 +1418,7 @@
       </p:sp>
       <p:sp>
         <p:nvSpPr>
-          <p:cNvPr id="7" name="Text 4"/>
+          <p:cNvPr id="8" name="Text 5"/>
           <p:cNvSpPr txBox="1"/>
           <p:nvPr/>
         </p:nvSpPr>
@@ -1418,7 +1457,7 @@
       </p:sp>
       <p:sp>
         <p:nvSpPr>
-          <p:cNvPr id="8" name="Text 5"/>
+          <p:cNvPr id="9" name="Text 6"/>
           <p:cNvSpPr txBox="1"/>
           <p:nvPr/>
         </p:nvSpPr>
@@ -1457,7 +1496,7 @@
       </p:sp>
       <p:sp>
         <p:nvSpPr>
-          <p:cNvPr id="9" name="Text 6"/>
+          <p:cNvPr id="10" name="Text 7"/>
           <p:cNvSpPr txBox="1"/>
           <p:nvPr/>
         </p:nvSpPr>
@@ -1539,7 +1578,7 @@
       </p:sp>
       <p:sp>
         <p:nvSpPr>
-          <p:cNvPr id="10" name="Shape 7"/>
+          <p:cNvPr id="11" name="Shape 8"/>
           <p:cNvSpPr/>
           <p:nvPr/>
         </p:nvSpPr>
@@ -3045,6 +3084,45 @@
               <a:t>tacirogluresearch.org</a:t>
             </a:r>
             <a:endParaRPr lang="en-US" sz="1800" dirty="0"/>
+          </a:p>
+        </p:txBody>
+      </p:sp>
+      <p:sp>
+        <p:nvSpPr>
+          <p:cNvPr id="9" name="Text 6"/>
+          <p:cNvSpPr txBox="1"/>
+          <p:nvPr/>
+        </p:nvSpPr>
+        <p:spPr>
+          <a:xfrm>
+            <a:off x="0" y="4754880"/>
+            <a:ext cx="12188952" cy="411480"/>
+          </a:xfrm>
+          <a:prstGeom prst="rect">
+            <a:avLst/>
+          </a:prstGeom>
+          <a:noFill/>
+          <a:ln/>
+        </p:spPr>
+        <p:txBody>
+          <a:bodyPr wrap="square" lIns="0" tIns="0" rIns="0" bIns="0" rtlCol="0" anchor="ctr"/>
+          <a:lstStyle/>
+          <a:p>
+            <a:pPr algn="ctr" indent="0" marL="0">
+              <a:buNone/>
+            </a:pPr>
+            <a:r>
+              <a:rPr lang="en-US" sz="1300" dirty="0">
+                <a:solidFill>
+                  <a:srgbClr val="C9D6D0"/>
+                </a:solidFill>
+                <a:latin typeface="Helvetica" pitchFamily="34" charset="0"/>
+                <a:ea typeface="Helvetica" pitchFamily="34" charset="-122"/>
+                <a:cs typeface="Helvetica" pitchFamily="34" charset="-120"/>
+              </a:rPr>
+              <a:t>UCLA  ·  Civil &amp; Environmental Engineering</a:t>
+            </a:r>
+            <a:endParaRPr lang="en-US" sz="1300" dirty="0"/>
           </a:p>
         </p:txBody>
       </p:sp>

</xml_diff>

<commit_message>
Templates: UCLA mark on closing slide only
</commit_message>
<xml_diff>
--- a/files/TRG-template-site.pptx
+++ b/files/TRG-template-site.pptx
@@ -1291,48 +1291,9 @@
           <a:ln/>
         </p:spPr>
       </p:sp>
-      <p:sp>
-        <p:nvSpPr>
-          <p:cNvPr id="5" name="Text 3"/>
-          <p:cNvSpPr txBox="1"/>
-          <p:nvPr/>
-        </p:nvSpPr>
-        <p:spPr>
-          <a:xfrm>
-            <a:off x="10497312" y="320040"/>
-            <a:ext cx="1188720" cy="502920"/>
-          </a:xfrm>
-          <a:prstGeom prst="rect">
-            <a:avLst/>
-          </a:prstGeom>
-          <a:noFill/>
-          <a:ln/>
-        </p:spPr>
-        <p:txBody>
-          <a:bodyPr wrap="square" lIns="0" tIns="0" rIns="0" bIns="0" rtlCol="0" anchor="ctr"/>
-          <a:lstStyle/>
-          <a:p>
-            <a:pPr algn="r" indent="0" marL="0">
-              <a:buNone/>
-            </a:pPr>
-            <a:r>
-              <a:rPr lang="en-US" sz="2600" b="1" i="1" dirty="0">
-                <a:solidFill>
-                  <a:srgbClr val="2774AE"/>
-                </a:solidFill>
-                <a:latin typeface="Helvetica" pitchFamily="34" charset="0"/>
-                <a:ea typeface="Helvetica" pitchFamily="34" charset="-122"/>
-                <a:cs typeface="Helvetica" pitchFamily="34" charset="-120"/>
-              </a:rPr>
-              <a:t>UCLA</a:t>
-            </a:r>
-            <a:endParaRPr lang="en-US" sz="2600" dirty="0"/>
-          </a:p>
-        </p:txBody>
-      </p:sp>
       <p:pic>
         <p:nvPicPr>
-          <p:cNvPr id="6" name="Image 0" descr="medallion-tri.png">    </p:cNvPr>
+          <p:cNvPr id="5" name="Image 0" descr="medallion-tri.png">    </p:cNvPr>
           <p:cNvPicPr>
             <a:picLocks noChangeAspect="1"/>
           </p:cNvPicPr>
@@ -1356,7 +1317,7 @@
       </p:pic>
       <p:sp>
         <p:nvSpPr>
-          <p:cNvPr id="7" name="Text 4"/>
+          <p:cNvPr id="6" name="Text 3"/>
           <p:cNvSpPr txBox="1"/>
           <p:nvPr/>
         </p:nvSpPr>
@@ -1418,7 +1379,7 @@
       </p:sp>
       <p:sp>
         <p:nvSpPr>
-          <p:cNvPr id="8" name="Text 5"/>
+          <p:cNvPr id="7" name="Text 4"/>
           <p:cNvSpPr txBox="1"/>
           <p:nvPr/>
         </p:nvSpPr>
@@ -1457,7 +1418,7 @@
       </p:sp>
       <p:sp>
         <p:nvSpPr>
-          <p:cNvPr id="9" name="Text 6"/>
+          <p:cNvPr id="8" name="Text 5"/>
           <p:cNvSpPr txBox="1"/>
           <p:nvPr/>
         </p:nvSpPr>
@@ -1496,7 +1457,7 @@
       </p:sp>
       <p:sp>
         <p:nvSpPr>
-          <p:cNvPr id="10" name="Text 7"/>
+          <p:cNvPr id="9" name="Text 6"/>
           <p:cNvSpPr txBox="1"/>
           <p:nvPr/>
         </p:nvSpPr>
@@ -1578,7 +1539,7 @@
       </p:sp>
       <p:sp>
         <p:nvSpPr>
-          <p:cNvPr id="11" name="Shape 8"/>
+          <p:cNvPr id="10" name="Shape 7"/>
           <p:cNvSpPr/>
           <p:nvPr/>
         </p:nvSpPr>

</xml_diff>